<commit_message>
✅ Completion totale : /prof, SUPPLEMENT notes, fiche PDF Ch8
Page /prof (tableau de bord enseignant) :
- 3 vues : Planning de cours, Ressources, Grille criteres
- Filtre par LO1/LO2/LO3/LO4
- 15 chapitres avec objectifs, duree, evaluation, liens jeu+exercice
- Stats : 25 PPTX, 15 fiches PDF, 33+ mini-jeux
- Exercices entreprise references
- Grille Pass/Merit/Distinction par LO
- Accessible via /prof (non indexe)

10 SUPPLEMENT PPTX avec notes professeur :
- Ch5-Ch14 supplements : exercices guides, questions de reflexion, recaps
- Chaque note inclut instructions pedagogiques, duree, conseils

Fiche PDF Ch8 Design Patterns :
- 7 patterns documentes (Singleton, Factory, Builder, Adapter, Composite, Observer, Strategy)
- Tableau 3 categories GoF
- Code Java pour chaque pattern
- Format fiche memo A4
</commit_message>
<xml_diff>
--- a/docs/pptx/Ch10_SUPPLEMENT.pptx
+++ b/docs/pptx/Ch10_SUPPLEMENT.pptx
@@ -504,10 +504,18 @@
           <a:lstStyle/>
           <a:p>
             <a:r>
-              <a:rPr lang="en-US" dirty="0"/>
-              <a:t/>
-            </a:r>
-            <a:endParaRPr lang="en-US" dirty="0"/>
+              <a:t>PROF: Exercice guidé — ajouter des exceptions à un projet existant.</a:t>
+            </a:r>
+          </a:p>
+          <a:p>
+            <a:r>
+              <a:t>1) Identifier les cas d'erreur 2) Créer une exception custom 3) Ajouter try-catch 4) Écrire les tests JUnit.</a:t>
+            </a:r>
+          </a:p>
+          <a:p>
+            <a:r>
+              <a:t>Durée : 45 min.</a:t>
+            </a:r>
           </a:p>
         </p:txBody>
       </p:sp>
@@ -592,10 +600,18 @@
           <a:lstStyle/>
           <a:p>
             <a:r>
-              <a:rPr lang="en-US" dirty="0"/>
-              <a:t/>
-            </a:r>
-            <a:endParaRPr lang="en-US" dirty="0"/>
+              <a:t>PROF: Questions sur le pattern AAA (Arrange-Act-Assert).</a:t>
+            </a:r>
+          </a:p>
+          <a:p>
+            <a:r>
+              <a:t>Demander d'identifier les 3 phases dans un test donné.</a:t>
+            </a:r>
+          </a:p>
+          <a:p>
+            <a:r>
+              <a:t>Piège : test qui fait Act avant Arrange.</a:t>
+            </a:r>
           </a:p>
         </p:txBody>
       </p:sp>
@@ -680,10 +696,13 @@
           <a:lstStyle/>
           <a:p>
             <a:r>
-              <a:rPr lang="en-US" dirty="0"/>
-              <a:t/>
-            </a:r>
-            <a:endParaRPr lang="en-US" dirty="0"/>
+              <a:t>PROF: Récap throw/throws/try-catch.</a:t>
+            </a:r>
+          </a:p>
+          <a:p>
+            <a:r>
+              <a:t>Exercice flash : donner 5 lignes de code, identifier laquelle lance, laquelle déclare, laquelle attrape.</a:t>
+            </a:r>
           </a:p>
         </p:txBody>
       </p:sp>
@@ -768,10 +787,18 @@
           <a:lstStyle/>
           <a:p>
             <a:r>
-              <a:rPr lang="en-US" dirty="0"/>
-              <a:t/>
-            </a:r>
-            <a:endParaRPr lang="en-US" dirty="0"/>
+              <a:t>PROF: Exception personnalisée — montrer StockInsuffisantException.</a:t>
+            </a:r>
+          </a:p>
+          <a:p>
+            <a:r>
+              <a:t>Expliquer quand créer ses propres exceptions vs utiliser les standards.</a:t>
+            </a:r>
+          </a:p>
+          <a:p>
+            <a:r>
+              <a:t>Règle : exception custom si le message standard n'est pas assez explicite.</a:t>
+            </a:r>
           </a:p>
         </p:txBody>
       </p:sp>

</xml_diff>